<commit_message>
small edits for pptx 2026 Days 1-3
</commit_message>
<xml_diff>
--- a/lessons/Day3/B_SyntacticParsing_lemmatization.pptx
+++ b/lessons/Day3/B_SyntacticParsing_lemmatization.pptx
@@ -240,7 +240,7 @@
           <a:p>
             <a:fld id="{B0C0A60C-850A-4EA4-9C14-A8FE98B94505}" type="datetimeFigureOut">
               <a:rPr lang="en-US" smtClean="0"/>
-              <a:t>6/24/25</a:t>
+              <a:t>6/7/26</a:t>
             </a:fld>
             <a:endParaRPr lang="en-US"/>
           </a:p>
@@ -741,7 +741,7 @@
           <a:p>
             <a:fld id="{5738B90E-0779-4C36-915C-6F05FCD89456}" type="datetime1">
               <a:rPr lang="en-US" smtClean="0"/>
-              <a:t>6/24/25</a:t>
+              <a:t>6/7/26</a:t>
             </a:fld>
             <a:endParaRPr lang="en-US"/>
           </a:p>
@@ -944,7 +944,7 @@
           <a:p>
             <a:fld id="{7B9EA29D-D431-42FE-B7B6-AAE4454C77D3}" type="datetime1">
               <a:rPr lang="en-US" smtClean="0"/>
-              <a:t>6/24/25</a:t>
+              <a:t>6/7/26</a:t>
             </a:fld>
             <a:endParaRPr lang="en-US"/>
           </a:p>
@@ -1224,7 +1224,7 @@
           <a:p>
             <a:fld id="{690D8A1E-EA8F-46C1-B891-AE0C00D9C314}" type="datetime1">
               <a:rPr lang="en-US" smtClean="0"/>
-              <a:t>6/24/25</a:t>
+              <a:t>6/7/26</a:t>
             </a:fld>
             <a:endParaRPr lang="en-US"/>
           </a:p>
@@ -1538,7 +1538,7 @@
           <a:p>
             <a:fld id="{D753EFC8-4232-4598-94F6-94C0EBAFC469}" type="datetime1">
               <a:rPr lang="en-US" smtClean="0"/>
-              <a:t>6/24/25</a:t>
+              <a:t>6/7/26</a:t>
             </a:fld>
             <a:endParaRPr lang="en-US"/>
           </a:p>
@@ -1873,7 +1873,7 @@
           <a:p>
             <a:fld id="{F3161074-1C18-4AE7-957D-F18524378C85}" type="datetime1">
               <a:rPr lang="en-US" smtClean="0"/>
-              <a:t>6/24/25</a:t>
+              <a:t>6/7/26</a:t>
             </a:fld>
             <a:endParaRPr lang="en-US"/>
           </a:p>
@@ -2132,7 +2132,7 @@
           <a:p>
             <a:fld id="{69BE256C-8D9A-4404-B47D-41A1AE514425}" type="datetime1">
               <a:rPr lang="en-US" smtClean="0"/>
-              <a:t>6/24/25</a:t>
+              <a:t>6/7/26</a:t>
             </a:fld>
             <a:endParaRPr lang="en-US"/>
           </a:p>
@@ -2586,7 +2586,7 @@
           <a:p>
             <a:fld id="{66CB2154-9035-4012-8189-BAAB61C5A5EE}" type="datetime1">
               <a:rPr lang="en-US" smtClean="0"/>
-              <a:t>6/24/25</a:t>
+              <a:t>6/7/26</a:t>
             </a:fld>
             <a:endParaRPr lang="en-US"/>
           </a:p>
@@ -2780,7 +2780,7 @@
           <a:p>
             <a:fld id="{6700A58B-DD98-43D0-B791-721480A02982}" type="datetime1">
               <a:rPr lang="en-US" smtClean="0"/>
-              <a:t>6/24/25</a:t>
+              <a:t>6/7/26</a:t>
             </a:fld>
             <a:endParaRPr lang="en-US"/>
           </a:p>
@@ -2992,7 +2992,7 @@
           <a:p>
             <a:fld id="{7DB6E382-4F61-4E24-BE1A-377EC83D0E3A}" type="datetime1">
               <a:rPr lang="en-US" smtClean="0"/>
-              <a:t>6/24/25</a:t>
+              <a:t>6/7/26</a:t>
             </a:fld>
             <a:endParaRPr lang="en-US"/>
           </a:p>
@@ -3323,7 +3323,7 @@
           <a:p>
             <a:fld id="{4142EED6-FC16-45B9-B8C4-2BC5DBA88325}" type="datetime1">
               <a:rPr lang="en-US" smtClean="0"/>
-              <a:t>6/24/25</a:t>
+              <a:t>6/7/26</a:t>
             </a:fld>
             <a:endParaRPr lang="en-US"/>
           </a:p>
@@ -3661,7 +3661,7 @@
           <a:p>
             <a:fld id="{DF59512B-4F1D-43D7-8819-2F53FEF69650}" type="datetime1">
               <a:rPr lang="en-US" smtClean="0"/>
-              <a:t>6/24/25</a:t>
+              <a:t>6/7/26</a:t>
             </a:fld>
             <a:endParaRPr lang="en-US"/>
           </a:p>
@@ -3957,7 +3957,7 @@
           <a:p>
             <a:fld id="{08437B94-E2BF-44DC-ADC5-B05FC9934E9D}" type="datetime1">
               <a:rPr lang="en-US" smtClean="0"/>
-              <a:t>6/24/25</a:t>
+              <a:t>6/7/26</a:t>
             </a:fld>
             <a:endParaRPr lang="en-US"/>
           </a:p>
@@ -4413,7 +4413,7 @@
           <a:p>
             <a:fld id="{5738B90E-0779-4C36-915C-6F05FCD89456}" type="datetime1">
               <a:rPr lang="en-US" smtClean="0"/>
-              <a:t>6/24/25</a:t>
+              <a:t>6/7/26</a:t>
             </a:fld>
             <a:endParaRPr lang="en-US"/>
           </a:p>
@@ -8600,7 +8600,7 @@
           <a:p>
             <a:fld id="{6700A58B-DD98-43D0-B791-721480A02982}" type="datetime1">
               <a:rPr lang="en-US" smtClean="0"/>
-              <a:t>6/24/25</a:t>
+              <a:t>6/7/26</a:t>
             </a:fld>
             <a:endParaRPr lang="en-US"/>
           </a:p>
@@ -8837,7 +8837,7 @@
             <a:fld id="{6700A58B-DD98-43D0-B791-721480A02982}" type="datetime1">
               <a:rPr lang="en-US" smtClean="0"/>
               <a:pPr/>
-              <a:t>6/24/25</a:t>
+              <a:t>6/7/26</a:t>
             </a:fld>
             <a:endParaRPr lang="en-US"/>
           </a:p>
@@ -8864,8 +8864,12 @@
           <a:lstStyle/>
           <a:p>
             <a:r>
-              <a:rPr lang="en-US"/>
-              <a:t>Institute of formal &amp; applies linguistics: UDPipe</a:t>
+              <a:rPr lang="en-US" dirty="0"/>
+              <a:t>Institute of formal &amp; applied linguistics: </a:t>
+            </a:r>
+            <a:r>
+              <a:rPr lang="en-US" dirty="0" err="1"/>
+              <a:t>UDPipe</a:t>
             </a:r>
             <a:endParaRPr lang="en-US" dirty="0"/>
           </a:p>
@@ -8916,10 +8920,9 @@
           <a:lstStyle/>
           <a:p>
             <a:r>
-              <a:rPr lang="en-US"/>
+              <a:rPr lang="en-US" dirty="0"/>
               <a:t>Kwartler</a:t>
             </a:r>
-            <a:endParaRPr lang="en-US" dirty="0"/>
           </a:p>
         </p:txBody>
       </p:sp>
@@ -9065,7 +9068,7 @@
           <a:p>
             <a:fld id="{6700A58B-DD98-43D0-B791-721480A02982}" type="datetime1">
               <a:rPr lang="en-US" smtClean="0"/>
-              <a:t>6/24/25</a:t>
+              <a:t>6/7/26</a:t>
             </a:fld>
             <a:endParaRPr lang="en-US"/>
           </a:p>
@@ -9307,7 +9310,7 @@
           <a:p>
             <a:fld id="{6700A58B-DD98-43D0-B791-721480A02982}" type="datetime1">
               <a:rPr lang="en-US" smtClean="0"/>
-              <a:t>6/24/25</a:t>
+              <a:t>6/7/26</a:t>
             </a:fld>
             <a:endParaRPr lang="en-US"/>
           </a:p>
@@ -9539,7 +9542,7 @@
 </file>
 
 <file path=ppt/slides/slide19.xml><?xml version="1.0" encoding="utf-8"?>
-<p:sld xmlns:a="http://schemas.openxmlformats.org/drawingml/2006/main" xmlns:r="http://schemas.openxmlformats.org/officeDocument/2006/relationships" xmlns:p="http://schemas.openxmlformats.org/presentationml/2006/main">
+<p:sld xmlns:a="http://schemas.openxmlformats.org/drawingml/2006/main" xmlns:r="http://schemas.openxmlformats.org/officeDocument/2006/relationships" xmlns:p="http://schemas.openxmlformats.org/presentationml/2006/main" show="0">
   <p:cSld>
     <p:spTree>
       <p:nvGrpSpPr>
@@ -9578,7 +9581,7 @@
           <a:p>
             <a:fld id="{6700A58B-DD98-43D0-B791-721480A02982}" type="datetime1">
               <a:rPr lang="en-US" smtClean="0"/>
-              <a:t>6/24/25</a:t>
+              <a:t>6/7/26</a:t>
             </a:fld>
             <a:endParaRPr lang="en-US"/>
           </a:p>
@@ -9727,7 +9730,7 @@
           <a:p>
             <a:fld id="{6700A58B-DD98-43D0-B791-721480A02982}" type="datetime1">
               <a:rPr lang="en-US" smtClean="0"/>
-              <a:t>6/24/25</a:t>
+              <a:t>6/7/26</a:t>
             </a:fld>
             <a:endParaRPr lang="en-US"/>
           </a:p>
@@ -10394,7 +10397,7 @@
 </file>
 
 <file path=ppt/slides/slide20.xml><?xml version="1.0" encoding="utf-8"?>
-<p:sld xmlns:a="http://schemas.openxmlformats.org/drawingml/2006/main" xmlns:r="http://schemas.openxmlformats.org/officeDocument/2006/relationships" xmlns:p="http://schemas.openxmlformats.org/presentationml/2006/main">
+<p:sld xmlns:a="http://schemas.openxmlformats.org/drawingml/2006/main" xmlns:r="http://schemas.openxmlformats.org/officeDocument/2006/relationships" xmlns:p="http://schemas.openxmlformats.org/presentationml/2006/main" show="0">
   <p:cSld>
     <p:spTree>
       <p:nvGrpSpPr>
@@ -10427,7 +10430,7 @@
           <a:p>
             <a:fld id="{6700A58B-DD98-43D0-B791-721480A02982}" type="datetime1">
               <a:rPr lang="en-US" smtClean="0"/>
-              <a:t>6/24/25</a:t>
+              <a:t>6/7/26</a:t>
             </a:fld>
             <a:endParaRPr lang="en-US"/>
           </a:p>
@@ -10563,7 +10566,7 @@
 </file>
 
 <file path=ppt/slides/slide21.xml><?xml version="1.0" encoding="utf-8"?>
-<p:sld xmlns:a="http://schemas.openxmlformats.org/drawingml/2006/main" xmlns:r="http://schemas.openxmlformats.org/officeDocument/2006/relationships" xmlns:p="http://schemas.openxmlformats.org/presentationml/2006/main">
+<p:sld xmlns:a="http://schemas.openxmlformats.org/drawingml/2006/main" xmlns:r="http://schemas.openxmlformats.org/officeDocument/2006/relationships" xmlns:p="http://schemas.openxmlformats.org/presentationml/2006/main" show="0">
   <p:cSld>
     <p:spTree>
       <p:nvGrpSpPr>
@@ -10596,7 +10599,7 @@
           <a:p>
             <a:fld id="{6700A58B-DD98-43D0-B791-721480A02982}" type="datetime1">
               <a:rPr lang="en-US" smtClean="0"/>
-              <a:t>6/24/25</a:t>
+              <a:t>6/7/26</a:t>
             </a:fld>
             <a:endParaRPr lang="en-US"/>
           </a:p>
@@ -10780,7 +10783,7 @@
 </file>
 
 <file path=ppt/slides/slide22.xml><?xml version="1.0" encoding="utf-8"?>
-<p:sld xmlns:a="http://schemas.openxmlformats.org/drawingml/2006/main" xmlns:r="http://schemas.openxmlformats.org/officeDocument/2006/relationships" xmlns:p="http://schemas.openxmlformats.org/presentationml/2006/main">
+<p:sld xmlns:a="http://schemas.openxmlformats.org/drawingml/2006/main" xmlns:r="http://schemas.openxmlformats.org/officeDocument/2006/relationships" xmlns:p="http://schemas.openxmlformats.org/presentationml/2006/main" show="0">
   <p:cSld>
     <p:spTree>
       <p:nvGrpSpPr>
@@ -10813,7 +10816,7 @@
           <a:p>
             <a:fld id="{6700A58B-DD98-43D0-B791-721480A02982}" type="datetime1">
               <a:rPr lang="en-US" smtClean="0"/>
-              <a:t>6/24/25</a:t>
+              <a:t>6/7/26</a:t>
             </a:fld>
             <a:endParaRPr lang="en-US"/>
           </a:p>
@@ -11249,7 +11252,7 @@
 </file>
 
 <file path=ppt/slides/slide23.xml><?xml version="1.0" encoding="utf-8"?>
-<p:sld xmlns:a="http://schemas.openxmlformats.org/drawingml/2006/main" xmlns:r="http://schemas.openxmlformats.org/officeDocument/2006/relationships" xmlns:p="http://schemas.openxmlformats.org/presentationml/2006/main">
+<p:sld xmlns:a="http://schemas.openxmlformats.org/drawingml/2006/main" xmlns:r="http://schemas.openxmlformats.org/officeDocument/2006/relationships" xmlns:p="http://schemas.openxmlformats.org/presentationml/2006/main" show="0">
   <p:cSld>
     <p:spTree>
       <p:nvGrpSpPr>
@@ -11282,7 +11285,7 @@
           <a:p>
             <a:fld id="{6700A58B-DD98-43D0-B791-721480A02982}" type="datetime1">
               <a:rPr lang="en-US" smtClean="0"/>
-              <a:t>6/24/25</a:t>
+              <a:t>6/7/26</a:t>
             </a:fld>
             <a:endParaRPr lang="en-US"/>
           </a:p>
@@ -11497,7 +11500,7 @@
 </file>
 
 <file path=ppt/slides/slide24.xml><?xml version="1.0" encoding="utf-8"?>
-<p:sld xmlns:a="http://schemas.openxmlformats.org/drawingml/2006/main" xmlns:r="http://schemas.openxmlformats.org/officeDocument/2006/relationships" xmlns:p="http://schemas.openxmlformats.org/presentationml/2006/main">
+<p:sld xmlns:a="http://schemas.openxmlformats.org/drawingml/2006/main" xmlns:r="http://schemas.openxmlformats.org/officeDocument/2006/relationships" xmlns:p="http://schemas.openxmlformats.org/presentationml/2006/main" show="0">
   <p:cSld>
     <p:spTree>
       <p:nvGrpSpPr>
@@ -11530,7 +11533,7 @@
           <a:p>
             <a:fld id="{6700A58B-DD98-43D0-B791-721480A02982}" type="datetime1">
               <a:rPr lang="en-US" smtClean="0"/>
-              <a:t>6/24/25</a:t>
+              <a:t>6/7/26</a:t>
             </a:fld>
             <a:endParaRPr lang="en-US"/>
           </a:p>
@@ -11731,7 +11734,7 @@
 </file>
 
 <file path=ppt/slides/slide25.xml><?xml version="1.0" encoding="utf-8"?>
-<p:sld xmlns:a="http://schemas.openxmlformats.org/drawingml/2006/main" xmlns:r="http://schemas.openxmlformats.org/officeDocument/2006/relationships" xmlns:p="http://schemas.openxmlformats.org/presentationml/2006/main">
+<p:sld xmlns:a="http://schemas.openxmlformats.org/drawingml/2006/main" xmlns:r="http://schemas.openxmlformats.org/officeDocument/2006/relationships" xmlns:p="http://schemas.openxmlformats.org/presentationml/2006/main" show="0">
   <p:cSld>
     <p:spTree>
       <p:nvGrpSpPr>
@@ -11764,7 +11767,7 @@
           <a:p>
             <a:fld id="{6700A58B-DD98-43D0-B791-721480A02982}" type="datetime1">
               <a:rPr lang="en-US" smtClean="0"/>
-              <a:t>6/24/25</a:t>
+              <a:t>6/7/26</a:t>
             </a:fld>
             <a:endParaRPr lang="en-US"/>
           </a:p>
@@ -12033,7 +12036,7 @@
 </file>
 
 <file path=ppt/slides/slide26.xml><?xml version="1.0" encoding="utf-8"?>
-<p:sld xmlns:a="http://schemas.openxmlformats.org/drawingml/2006/main" xmlns:r="http://schemas.openxmlformats.org/officeDocument/2006/relationships" xmlns:p="http://schemas.openxmlformats.org/presentationml/2006/main">
+<p:sld xmlns:a="http://schemas.openxmlformats.org/drawingml/2006/main" xmlns:r="http://schemas.openxmlformats.org/officeDocument/2006/relationships" xmlns:p="http://schemas.openxmlformats.org/presentationml/2006/main" show="0">
   <p:cSld>
     <p:spTree>
       <p:nvGrpSpPr>
@@ -12066,7 +12069,7 @@
           <a:p>
             <a:fld id="{6700A58B-DD98-43D0-B791-721480A02982}" type="datetime1">
               <a:rPr lang="en-US" smtClean="0"/>
-              <a:t>6/24/25</a:t>
+              <a:t>6/7/26</a:t>
             </a:fld>
             <a:endParaRPr lang="en-US"/>
           </a:p>
@@ -12548,7 +12551,7 @@
 </file>
 
 <file path=ppt/slides/slide27.xml><?xml version="1.0" encoding="utf-8"?>
-<p:sld xmlns:a="http://schemas.openxmlformats.org/drawingml/2006/main" xmlns:r="http://schemas.openxmlformats.org/officeDocument/2006/relationships" xmlns:p="http://schemas.openxmlformats.org/presentationml/2006/main">
+<p:sld xmlns:a="http://schemas.openxmlformats.org/drawingml/2006/main" xmlns:r="http://schemas.openxmlformats.org/officeDocument/2006/relationships" xmlns:p="http://schemas.openxmlformats.org/presentationml/2006/main" show="0">
   <p:cSld>
     <p:spTree>
       <p:nvGrpSpPr>
@@ -12581,7 +12584,7 @@
           <a:p>
             <a:fld id="{6700A58B-DD98-43D0-B791-721480A02982}" type="datetime1">
               <a:rPr lang="en-US" smtClean="0"/>
-              <a:t>6/24/25</a:t>
+              <a:t>6/7/26</a:t>
             </a:fld>
             <a:endParaRPr lang="en-US"/>
           </a:p>

</xml_diff>